<commit_message>
docs(slides): refine deck and add speaker script
</commit_message>
<xml_diff>
--- a/slides/token-optimizer-reworked-deck.pptx
+++ b/slides/token-optimizer-reworked-deck.pptx
@@ -10883,7 +10883,7 @@
                   <a:srgbClr val="101827"/>
                 </a:solidFill>
               </a:rPr>
-              <a:t>Ponytail: hạn chế xây vượt phạm vi</a:t>
+              <a:t>Giới hạn phạm vi code và abstraction được phép tạo</a:t>
             </a:r>
           </a:p>
         </p:txBody>
@@ -11017,7 +11017,7 @@
                   <a:srgbClr val="101827"/>
                 </a:solidFill>
               </a:rPr>
-              <a:t>Caveman (skill): rút gọn phần diễn giải</a:t>
+              <a:t>Yêu cầu phần diễn giải ngắn, đi thẳng vào kết quả</a:t>
             </a:r>
           </a:p>
         </p:txBody>
@@ -11525,7 +11525,7 @@
                   <a:srgbClr val="C43C4E"/>
                 </a:solidFill>
               </a:rPr>
-              <a:t>Giới hạn phần agent xây dựng</a:t>
+              <a:t>Ưu tiên tái sử dụng; chỉ xây phần tối thiểu cần thiết.</a:t>
             </a:r>
           </a:p>
         </p:txBody>
@@ -11660,7 +11660,7 @@
                   <a:srgbClr val="D97706"/>
                 </a:solidFill>
               </a:rPr>
-              <a:t>Giảm prose trong đầu ra</a:t>
+              <a:t>Rút ngắn văn xuôi; không nén code, diff hay kết quả tool.</a:t>
             </a:r>
           </a:p>
         </p:txBody>
@@ -11711,7 +11711,7 @@
                   <a:srgbClr val="6246B5"/>
                 </a:solidFill>
               </a:rPr>
-              <a:t>Ponytail và Caveman cùng tác động tại node lần gọi model, nhưng giải quyết hai vấn đề khác nhau.</a:t>
+              <a:t>Ponytail kiểm soát phần được xây; Caveman kiểm soát độ dài phần được nói.</a:t>
             </a:r>
           </a:p>
         </p:txBody>
@@ -12904,7 +12904,7 @@
                   <a:srgbClr val="101827"/>
                 </a:solidFill>
               </a:rPr>
-              <a:t>CodeGraph: xem quan hệ symbol, caller và impact</a:t>
+              <a:t>Dùng chỉ mục code để xác định symbol, caller và impact</a:t>
             </a:r>
           </a:p>
         </p:txBody>
@@ -13681,7 +13681,7 @@
                   <a:srgbClr val="16845B"/>
                 </a:solidFill>
               </a:rPr>
-              <a:t>chỉ ra quan hệ cần xem, rồi đọc đúng file</a:t>
+              <a:t>Lập graph code local để hỏi symbol, caller và impact.</a:t>
             </a:r>
           </a:p>
         </p:txBody>
@@ -13732,7 +13732,7 @@
                   <a:srgbClr val="6246B5"/>
                 </a:solidFill>
               </a:rPr>
-              <a:t>CodeGraph phù hợp khi vấn đề là định vị và hiểu quan hệ trong repo lớn.</a:t>
+              <a:t>CodeGraph giảm các vòng search/read khi agent cần hiểu quan hệ trong repo lớn.</a:t>
             </a:r>
           </a:p>
         </p:txBody>
@@ -14925,7 +14925,7 @@
                   <a:srgbClr val="101827"/>
                 </a:solidFill>
               </a:rPr>
-              <a:t>RTK: rút gọn build, test và linter output</a:t>
+              <a:t>Lọc và rút gọn build, test hoặc linter output</a:t>
             </a:r>
           </a:p>
         </p:txBody>
@@ -15681,7 +15681,7 @@
                   <a:srgbClr val="64748B"/>
                 </a:solidFill>
               </a:rPr>
-              <a:t>RTK / LIMIT</a:t>
+              <a:t>RTK</a:t>
             </a:r>
           </a:p>
           <a:p xmlns:a="http://schemas.openxmlformats.org/drawingml/2006/main">
@@ -15702,7 +15702,7 @@
                   <a:srgbClr val="64748B"/>
                 </a:solidFill>
               </a:rPr>
-              <a:t>tóm tắt lỗi</a:t>
+              <a:t>lọc output</a:t>
             </a:r>
           </a:p>
         </p:txBody>
@@ -16023,7 +16023,7 @@
                   <a:srgbClr val="6246B5"/>
                 </a:solidFill>
               </a:rPr>
-              <a:t>RTK nằm trên cạnh tool trả kết quả: giảm payload trước khi nó đi vào context.</a:t>
+              <a:t>RTK lọc, gom nhóm, cắt và khử trùng lặp shell output trước khi nó đi vào context.</a:t>
             </a:r>
           </a:p>
         </p:txBody>
@@ -31942,7 +31942,7 @@
                   <a:srgbClr val="334155"/>
                 </a:solidFill>
               </a:rPr>
-              <a:t>System / developer instructions</a:t>
+              <a:t>Context được gửi vào mỗi lần gọi model</a:t>
             </a:r>
           </a:p>
         </p:txBody>
@@ -32025,7 +32025,7 @@
                   <a:srgbClr val="334155"/>
                 </a:solidFill>
               </a:rPr>
-              <a:t>Rules, tool schemas, history</a:t>
+              <a:t>Kết quả tool từ vòng trước trở thành input</a:t>
             </a:r>
           </a:p>
         </p:txBody>
@@ -32108,7 +32108,7 @@
                   <a:srgbClr val="334155"/>
                 </a:solidFill>
               </a:rPr>
-              <a:t>User message, files, retrieval</a:t>
+              <a:t>Cache chỉ giảm đơn giá cho phần được sử dụng lại</a:t>
             </a:r>
           </a:p>
         </p:txBody>
@@ -32191,7 +32191,7 @@
                   <a:srgbClr val="334155"/>
                 </a:solidFill>
               </a:rPr>
-              <a:t>Tool results được append</a:t>
+              <a:t>Input lặp lại vẫn chiếm context window</a:t>
             </a:r>
           </a:p>
         </p:txBody>
@@ -32388,7 +32388,7 @@
                   <a:srgbClr val="334155"/>
                 </a:solidFill>
               </a:rPr>
-              <a:t>Reasoning / thinking nếu được tính</a:t>
+              <a:t>Reasoning, tool call và final response</a:t>
             </a:r>
           </a:p>
         </p:txBody>
@@ -32471,7 +32471,7 @@
                   <a:srgbClr val="334155"/>
                 </a:solidFill>
               </a:rPr>
-              <a:t>Tool call do model sinh ra</a:t>
+              <a:t>Output thường có đơn giá cao hơn input</a:t>
             </a:r>
           </a:p>
         </p:txBody>
@@ -32554,7 +32554,7 @@
                   <a:srgbClr val="334155"/>
                 </a:solidFill>
               </a:rPr>
-              <a:t>Final response</a:t>
+              <a:t>Trả lời ngắn chưa chắc làm cả task rẻ hơn</a:t>
             </a:r>
           </a:p>
         </p:txBody>

</xml_diff>